<commit_message>
Role-of-Store slide: embed reference-style donut chart as PNG
Replaced pptxgenjs's built-in chart with a matplotlib-rendered PNG
that matches the user's reference image exactly:
  - Same 5 equal 20% segments
  - Same color order (High Growth blue / Defend red / Neutral gray /
    Growth green / Maintain orange)
  - Legend laid out as 3 columns x 2 rows below the chart
  - Light paper background blending with the slide

Right-side cards (5 distinct roles) unchanged.

Co-Authored-By: Claude Opus 4.6 (1M context) <noreply@anthropic.com>
</commit_message>
<xml_diff>
--- a/outputs/Capstone8_RoleOfStore_Improved.pptx
+++ b/outputs/Capstone8_RoleOfStore_Improved.pptx
@@ -105,334 +105,6 @@
     </a:lvl9pPr>
   </p:defaultTextStyle>
 </p:presentation>
-</file>
-
-<file path=ppt/charts/chart1.xml><?xml version="1.0" encoding="utf-8"?>
-<c:chartSpace xmlns:c="http://schemas.openxmlformats.org/drawingml/2006/chart" xmlns:a="http://schemas.openxmlformats.org/drawingml/2006/main" xmlns:r="http://schemas.openxmlformats.org/officeDocument/2006/relationships">
-  <c:date1904 val="0"/>
-  <c:roundedCorners val="1"/>
-  <c:chart>
-    <c:autoTitleDeleted val="1"/>
-    <c:plotArea>
-      <c:layout/>
-      <c:doughnutChart>
-        <c:varyColors val="1"/>
-        <c:ser>
-          <c:idx val="0"/>
-          <c:order val="0"/>
-          <c:tx>
-            <c:strRef>
-              <c:f>Sheet1!$B$1</c:f>
-              <c:strCache>
-                <c:ptCount val="1"/>
-                <c:pt idx="0">
-                  <c:v>Roles</c:v>
-                </c:pt>
-              </c:strCache>
-            </c:strRef>
-          </c:tx>
-          <c:spPr>
-            <a:solidFill>
-              <a:schemeClr val="accent1"/>
-            </a:solidFill>
-            <a:ln w="9525" cap="flat">
-              <a:solidFill>
-                <a:srgbClr val="F9F9F9"/>
-              </a:solidFill>
-              <a:prstDash val="solid"/>
-              <a:round/>
-            </a:ln>
-            <a:effectLst/>
-          </c:spPr>
-          <c:dPt>
-            <c:idx val="0"/>
-            <c:bubble3D val="0"/>
-            <c:spPr>
-              <a:solidFill>
-                <a:srgbClr val="1565C0"/>
-              </a:solidFill>
-              <a:effectLst/>
-            </c:spPr>
-          </c:dPt>
-          <c:dPt>
-            <c:idx val="1"/>
-            <c:bubble3D val="0"/>
-            <c:spPr>
-              <a:solidFill>
-                <a:srgbClr val="43A047"/>
-              </a:solidFill>
-              <a:effectLst/>
-            </c:spPr>
-          </c:dPt>
-          <c:dPt>
-            <c:idx val="2"/>
-            <c:bubble3D val="0"/>
-            <c:spPr>
-              <a:solidFill>
-                <a:srgbClr val="757575"/>
-              </a:solidFill>
-              <a:effectLst/>
-            </c:spPr>
-          </c:dPt>
-          <c:dPt>
-            <c:idx val="3"/>
-            <c:bubble3D val="0"/>
-            <c:spPr>
-              <a:solidFill>
-                <a:srgbClr val="FF8F00"/>
-              </a:solidFill>
-              <a:effectLst/>
-            </c:spPr>
-          </c:dPt>
-          <c:dPt>
-            <c:idx val="4"/>
-            <c:bubble3D val="0"/>
-            <c:spPr>
-              <a:solidFill>
-                <a:srgbClr val="C62828"/>
-              </a:solidFill>
-              <a:effectLst/>
-            </c:spPr>
-          </c:dPt>
-          <c:dLbls>
-            <c:dLbl>
-              <c:idx val="0"/>
-              <c:numFmt formatCode="0%" sourceLinked="0"/>
-              <c:spPr/>
-              <c:txPr>
-                <a:bodyPr/>
-                <a:lstStyle/>
-                <a:p>
-                  <a:pPr>
-                    <a:defRPr sz="1200" b="1" i="0" u="none" strike="noStrike">
-                      <a:solidFill>
-                        <a:srgbClr val="FFFFFF"/>
-                      </a:solidFill>
-                      <a:latin typeface="Arial"/>
-                    </a:defRPr>
-                  </a:pPr>
-                </a:p>
-              </c:txPr>
-              <c:showLegendKey val="0"/>
-              <c:showVal val="0"/>
-              <c:showCatName val="0"/>
-              <c:showSerName val="0"/>
-              <c:showPercent val="1"/>
-              <c:showBubbleSize val="0"/>
-            </c:dLbl>
-            <c:dLbl>
-              <c:idx val="1"/>
-              <c:numFmt formatCode="0%" sourceLinked="0"/>
-              <c:spPr/>
-              <c:txPr>
-                <a:bodyPr/>
-                <a:lstStyle/>
-                <a:p>
-                  <a:pPr>
-                    <a:defRPr sz="1200" b="1" i="0" u="none" strike="noStrike">
-                      <a:solidFill>
-                        <a:srgbClr val="FFFFFF"/>
-                      </a:solidFill>
-                      <a:latin typeface="Arial"/>
-                    </a:defRPr>
-                  </a:pPr>
-                </a:p>
-              </c:txPr>
-              <c:showLegendKey val="0"/>
-              <c:showVal val="0"/>
-              <c:showCatName val="0"/>
-              <c:showSerName val="0"/>
-              <c:showPercent val="1"/>
-              <c:showBubbleSize val="0"/>
-            </c:dLbl>
-            <c:dLbl>
-              <c:idx val="2"/>
-              <c:numFmt formatCode="0%" sourceLinked="0"/>
-              <c:spPr/>
-              <c:txPr>
-                <a:bodyPr/>
-                <a:lstStyle/>
-                <a:p>
-                  <a:pPr>
-                    <a:defRPr sz="1200" b="1" i="0" u="none" strike="noStrike">
-                      <a:solidFill>
-                        <a:srgbClr val="FFFFFF"/>
-                      </a:solidFill>
-                      <a:latin typeface="Arial"/>
-                    </a:defRPr>
-                  </a:pPr>
-                </a:p>
-              </c:txPr>
-              <c:showLegendKey val="0"/>
-              <c:showVal val="0"/>
-              <c:showCatName val="0"/>
-              <c:showSerName val="0"/>
-              <c:showPercent val="1"/>
-              <c:showBubbleSize val="0"/>
-            </c:dLbl>
-            <c:dLbl>
-              <c:idx val="3"/>
-              <c:numFmt formatCode="0%" sourceLinked="0"/>
-              <c:spPr/>
-              <c:txPr>
-                <a:bodyPr/>
-                <a:lstStyle/>
-                <a:p>
-                  <a:pPr>
-                    <a:defRPr sz="1200" b="1" i="0" u="none" strike="noStrike">
-                      <a:solidFill>
-                        <a:srgbClr val="FFFFFF"/>
-                      </a:solidFill>
-                      <a:latin typeface="Arial"/>
-                    </a:defRPr>
-                  </a:pPr>
-                </a:p>
-              </c:txPr>
-              <c:showLegendKey val="0"/>
-              <c:showVal val="0"/>
-              <c:showCatName val="0"/>
-              <c:showSerName val="0"/>
-              <c:showPercent val="1"/>
-              <c:showBubbleSize val="0"/>
-            </c:dLbl>
-            <c:dLbl>
-              <c:idx val="4"/>
-              <c:numFmt formatCode="0%" sourceLinked="0"/>
-              <c:spPr/>
-              <c:txPr>
-                <a:bodyPr/>
-                <a:lstStyle/>
-                <a:p>
-                  <a:pPr>
-                    <a:defRPr sz="1200" b="1" i="0" u="none" strike="noStrike">
-                      <a:solidFill>
-                        <a:srgbClr val="FFFFFF"/>
-                      </a:solidFill>
-                      <a:latin typeface="Arial"/>
-                    </a:defRPr>
-                  </a:pPr>
-                </a:p>
-              </c:txPr>
-              <c:showLegendKey val="0"/>
-              <c:showVal val="0"/>
-              <c:showCatName val="0"/>
-              <c:showSerName val="0"/>
-              <c:showPercent val="1"/>
-              <c:showBubbleSize val="0"/>
-            </c:dLbl>
-            <c:numFmt formatCode="0%" sourceLinked="0"/>
-            <c:txPr>
-              <a:bodyPr/>
-              <a:lstStyle/>
-              <a:p>
-                <a:pPr>
-                  <a:defRPr sz="1800" b="1" i="0" u="none" strike="noStrike">
-                    <a:solidFill>
-                      <a:srgbClr val="000000"/>
-                    </a:solidFill>
-                    <a:latin typeface="Arial"/>
-                  </a:defRPr>
-                </a:pPr>
-              </a:p>
-            </c:txPr>
-            <c:showLegendKey val="0"/>
-            <c:showVal val="0"/>
-            <c:showCatName val="1"/>
-            <c:showSerName val="0"/>
-            <c:showPercent val="1"/>
-            <c:showBubbleSize val="0"/>
-            <c:showLeaderLines val="0"/>
-          </c:dLbls>
-          <c:cat>
-            <c:strRef>
-              <c:f>Sheet1!$A$2:$A$6</c:f>
-              <c:strCache>
-                <c:ptCount val="5"/>
-                <c:pt idx="0">
-                  <c:v>High Growth</c:v>
-                </c:pt>
-                <c:pt idx="1">
-                  <c:v>Growth</c:v>
-                </c:pt>
-                <c:pt idx="2">
-                  <c:v>Neutral</c:v>
-                </c:pt>
-                <c:pt idx="3">
-                  <c:v>Maintain</c:v>
-                </c:pt>
-                <c:pt idx="4">
-                  <c:v>Defend</c:v>
-                </c:pt>
-              </c:strCache>
-            </c:strRef>
-          </c:cat>
-          <c:val>
-            <c:numRef>
-              <c:f>Sheet1!$B$2:$B$6</c:f>
-              <c:numCache>
-                <c:ptCount val="5"/>
-                <c:pt idx="0">
-                  <c:v>346</c:v>
-                </c:pt>
-                <c:pt idx="1">
-                  <c:v>345</c:v>
-                </c:pt>
-                <c:pt idx="2">
-                  <c:v>345</c:v>
-                </c:pt>
-                <c:pt idx="3">
-                  <c:v>346</c:v>
-                </c:pt>
-                <c:pt idx="4">
-                  <c:v>345</c:v>
-                </c:pt>
-              </c:numCache>
-            </c:numRef>
-          </c:val>
-        </c:ser>
-        <c:firstSliceAng val="0"/>
-        <c:holeSize val="55"/>
-      </c:doughnutChart>
-      <c:spPr>
-        <a:noFill/>
-        <a:ln>
-          <a:noFill/>
-        </a:ln>
-        <a:effectLst/>
-      </c:spPr>
-    </c:plotArea>
-    <c:legend>
-      <c:legendPos val="b"/>
-      <c:overlay val="0"/>
-      <c:txPr>
-        <a:bodyPr/>
-        <a:lstStyle/>
-        <a:p>
-          <a:pPr>
-            <a:defRPr sz="1100">
-              <a:solidFill>
-                <a:srgbClr val="1A2332"/>
-              </a:solidFill>
-            </a:defRPr>
-          </a:pPr>
-          <a:endParaRPr lang="en-US"/>
-        </a:p>
-      </c:txPr>
-    </c:legend>
-    <c:plotVisOnly val="1"/>
-    <c:dispBlanksAs val="span"/>
-  </c:chart>
-  <c:spPr>
-    <a:noFill/>
-    <a:ln>
-      <a:noFill/>
-    </a:ln>
-    <a:effectLst/>
-  </c:spPr>
-  <c:externalData r:id="rId1">
-    <c:autoUpdate val="0"/>
-  </c:externalData>
-</c:chartSpace>
 </file>
 
 <file path=ppt/notesMasters/notesMaster1.xml><?xml version="1.0" encoding="utf-8"?>
@@ -1314,22 +986,29 @@
           </a:p>
         </p:txBody>
       </p:sp>
-      <p:graphicFrame>
-        <p:nvGraphicFramePr>
-          <p:cNvPr id="5" name="Chart 0" descr=""/>
-          <p:cNvGraphicFramePr/>
-          <p:nvPr/>
-        </p:nvGraphicFramePr>
-        <p:xfrm>
-          <a:off x="365760" y="2011680"/>
-          <a:ext cx="5120640" cy="4389120"/>
-        </p:xfrm>
-        <a:graphic xmlns:a="http://schemas.openxmlformats.org/drawingml/2006/main">
-          <a:graphicData uri="http://schemas.openxmlformats.org/drawingml/2006/chart">
-            <c:chart xmlns:c="http://schemas.openxmlformats.org/drawingml/2006/chart" r:id="rId1"/>
-          </a:graphicData>
-        </a:graphic>
-      </p:graphicFrame>
+      <p:pic>
+        <p:nvPicPr>
+          <p:cNvPr id="5" name="Image 0" descr="outputs/role_donut_reference.png">    </p:cNvPr>
+          <p:cNvPicPr>
+            <a:picLocks noChangeAspect="1"/>
+          </p:cNvPicPr>
+          <p:nvPr/>
+        </p:nvPicPr>
+        <p:blipFill>
+          <a:blip r:embed="rId1"/>
+          <a:srcRect l="0" r="0" t="0" b="0"/>
+          <a:stretch/>
+        </p:blipFill>
+        <p:spPr>
+          <a:xfrm>
+            <a:off x="457200" y="1737360"/>
+            <a:ext cx="5120640" cy="4572000"/>
+          </a:xfrm>
+          <a:prstGeom prst="rect">
+            <a:avLst/>
+          </a:prstGeom>
+        </p:spPr>
+      </p:pic>
       <p:sp>
         <p:nvSpPr>
           <p:cNvPr id="6" name="Text 3"/>
@@ -1338,8 +1017,8 @@
         </p:nvSpPr>
         <p:spPr>
           <a:xfrm>
-            <a:off x="365760" y="6309360"/>
-            <a:ext cx="5120640" cy="274320"/>
+            <a:off x="365760" y="6355080"/>
+            <a:ext cx="5303520" cy="274320"/>
           </a:xfrm>
           <a:prstGeom prst="rect">
             <a:avLst/>

</xml_diff>